<commit_message>
Add presentation script and put it in the deck's speaker notes
Slide-by-slide spoken script with timing and stage cues, plus prepared
answers to likely panel questions.

Co-Authored-By: Claude Opus 5.5 <noreply@anthropic.com>
Claude-Session: https://claude.ai/code/session_013E49sPYUyrRbFMqwEdxWwu
</commit_message>
<xml_diff>
--- a/research/Lagera_AI_Customer_Support_Presentation.pptx
+++ b/research/Lagera_AI_Customer_Support_Presentation.pptx
@@ -129,7 +129,7 @@
   <p:extLst>
     <p:ext uri="{521415D9-36F7-43E2-AB2F-B90AF26B5E84}">
       <p14:sectionLst xmlns:p14="http://schemas.microsoft.com/office/powerpoint/2010/main">
-        <p14:section name="Introduction" id="{27c230bd-c636-8ff9-45a9-cbf0de084f1b}">
+        <p14:section name="Introduction" id="{ca660ae6-7c1d-65e1-6d94-057c684ac048}">
           <p14:sldIdLst>
             <p14:sldId id="256"/>
             <p14:sldId id="257"/>
@@ -139,19 +139,19 @@
             <p14:sldId id="261"/>
           </p14:sldIdLst>
         </p14:section>
-        <p14:section name="Literature" id="{2928397d-b35b-f1b0-1fc3-2cafda248503}">
+        <p14:section name="Literature" id="{8c0f3f13-0dcb-c2f9-38c7-addb970ca974}">
           <p14:sldIdLst>
             <p14:sldId id="262"/>
             <p14:sldId id="263"/>
           </p14:sldIdLst>
         </p14:section>
-        <p14:section name="Methodology" id="{c99e1c6e-86f6-293f-4b28-1070be9ca24c}">
+        <p14:section name="Methodology" id="{4734ae7f-7f33-9f0b-fd9b-ec8568c75096}">
           <p14:sldIdLst>
             <p14:sldId id="264"/>
             <p14:sldId id="265"/>
           </p14:sldIdLst>
         </p14:section>
-        <p14:section name="System Design" id="{61cd8824-e38e-611b-ae9a-d0a75f38915c}">
+        <p14:section name="System Design" id="{e76e99ce-f5cf-c592-c444-ba22672d83b3}">
           <p14:sldIdLst>
             <p14:sldId id="266"/>
             <p14:sldId id="267"/>
@@ -163,13 +163,13 @@
             <p14:sldId id="273"/>
           </p14:sldIdLst>
         </p14:section>
-        <p14:section name="Evaluation" id="{eb802d83-4190-1de8-e7b4-57476a7eae49}">
+        <p14:section name="Evaluation" id="{ea4a56e8-de0c-1ea8-79de-58d721082055}">
           <p14:sldIdLst>
             <p14:sldId id="274"/>
             <p14:sldId id="275"/>
           </p14:sldIdLst>
         </p14:section>
-        <p14:section name="Conclusion" id="{142e767d-b27d-44ff-3e9d-8078aeebb864}">
+        <p14:section name="Conclusion" id="{406a0fb4-309b-ff26-a9e6-86cadf6e73da}">
           <p14:sldIdLst>
             <p14:sldId id="276"/>
             <p14:sldId id="277"/>
@@ -580,7 +580,9 @@
           <a:p>
             <a:r>
               <a:rPr lang="en-US" dirty="0"/>
-              <a:t>Good day po. My research is a design project: an AI-assisted customer support system for micro and small online sellers in Baguio City and Benguet. It answers routine customer questions using only the seller's approved information and passes complaints and difficult cases to a person.</a:t>
+              <a:t>[0:30]  Stand, smile, wait for the room to settle.
+Good morning po. My name is Jeanalyn Marie Lagera, and today I will present my design project for MITO 611, titled "Design of an AI-Assisted Customer Support System for Micro and Small E-Commerce Businesses in Baguio City and Benguet."
+In short, I am designing a tool that helps small online sellers answer their customers' routine questions, using only information the seller has approved, and passing the difficult conversations to a real person.</a:t>
             </a:r>
             <a:endParaRPr lang="en-US" dirty="0"/>
           </a:p>
@@ -668,7 +670,12 @@
           <a:p>
             <a:r>
               <a:rPr lang="en-US" dirty="0"/>
-              <a:t>Four options were compared. A, manual and saved replies, costs nothing but doesn't save time. B, a keyword bot, breaks on Taglish spellings like 'hm po' and 'mgkano'. C, a general AI chatbot, reads Taglish well but may invent a price or return period the shop never set. D, the proposed design, keeps the language ability but answers only from the owner's records and hands off to staff. D was selected.</a:t>
+              <a:t>[1:15]  Walk across the columns, end on the red column.
+Before choosing a design, I compared four options.
+Option A is what many sellers do now: type replies or use saved replies. It's free, but it doesn't save time.
+Option B is a keyword bot. It's cheap, but it breaks easily with Taglish spellings like "hm po" or "mgkano."
+Option C is a general AI chatbot. It understands Taglish well, but it answers from general knowledge, so it might quote a price or a return period that the shop never set.
+Option D is my proposal. It keeps the language ability of AI, but every answer must come from the owner's own records, and there is a clear hand-off to staff. That is why I chose D.</a:t>
             </a:r>
             <a:endParaRPr lang="en-US" dirty="0"/>
           </a:p>
@@ -756,7 +763,9 @@
           <a:p>
             <a:r>
               <a:rPr lang="en-US" dirty="0"/>
-              <a:t>Inputs: the customer's message, the owner's approved records, and escalation rules. Process: language and intent detection, retrieval, grounded generation, a confidence check, and escalation. Output: an answer traceable to a record, or a hand-off to staff. Privacy, security, human oversight and transparency apply to every stage. The feedback loop: when logs show a question with no matching record, the owner adds one.</a:t>
+              <a:t>[0:45]  Trace input, process, output with your hand.
+This is the conceptual framework. The inputs are the customer's message, the owner's approved records, and the escalation rules. The process detects the language and intent, retrieves the right record, writes a short answer, and checks its confidence. The output is either an answer that can be traced to a record, or a hand-off to staff.
+At the bottom are the controls that apply everywhere: privacy, security, human oversight, and transparency. And at the top is the feedback loop. When a question has no matching record, the owner simply adds one.</a:t>
             </a:r>
             <a:endParaRPr lang="en-US" dirty="0"/>
           </a:p>
@@ -844,7 +853,12 @@
           <a:p>
             <a:r>
               <a:rPr lang="en-US" dirty="0"/>
-              <a:t>Walk through the flowchart. Sensitive numbers are masked first. Language and intent are detected. Complaints, refunds and disputes go straight to staff. Other questions go to retrieval, which searches only this seller's active records. If a record passes the confidence threshold, the reply is generated from it and the record ID is logged. If not, the chat is escalated. The system never guesses a price or policy.</a:t>
+              <a:t>[1:30]  Use the three example cards to walk the flowchart.
+Here is how each message actually moves through the system.
+First, sensitive data like card numbers is masked. Then the system detects the language and the intent.
+Take the first example: "Available pa po ba ang Arabica 250g?" The system sees a stock question, finds the product record, and answers: "Yes po, in stock, 380 pesos."
+Second example: "Wrong item po ang dumating, I want a refund." That is a complaint, so it goes straight to the staff queue. The bot doesn't try to handle it.
+Third: if no record is a good enough match, the system does not guess. It escalates. And when staff answer, the owner can save that answer as a new FAQ for next time.</a:t>
             </a:r>
             <a:endParaRPr lang="en-US" dirty="0"/>
           </a:p>
@@ -932,7 +946,9 @@
           <a:p>
             <a:r>
               <a:rPr lang="en-US" dirty="0"/>
-              <a:t>Four layers: presentation (customer chat and owner dashboard), application (REST API, login, business rules, escalation queue), AI orchestration (language and intent, retriever, grounded generation and confidence check), and data (relational database plus vector index). Key design choice: the language model owns no data and cannot take any action. This follows NIST and OWASP guidance.</a:t>
+              <a:t>[0:50]  Point to the right-side points one by one.
+The architecture has four layers: presentation, application, AI orchestration, and data.
+The key design choice is this: the AI owns no data and cannot take any action. It receives text and returns text. The application code decides which records the AI can see, filtered by business, and whether a reply is sent. And the AI provider can be switched later without rebuilding the system.</a:t>
             </a:r>
             <a:endParaRPr lang="en-US" dirty="0"/>
           </a:p>
@@ -1020,7 +1036,9 @@
           <a:p>
             <a:r>
               <a:rPr lang="en-US" dirty="0"/>
-              <a:t>Left: the customer asks, picks quick topics, requests a person and rates answers. Owners and staff manage products, FAQs and policies and handle escalations. The AI service only takes part in 'retrieve and answer.' Right: a business has products, knowledge items and conversations; each message stores the intent, confidence and the knowledge item used, so every answer is auditable. Customers are identified by a reference code, not by name.</a:t>
+              <a:t>[0:40]  Left diagram, then right diagram.
+On the left is the use case diagram. Customers ask questions, choose quick topics, request a person, and rate answers. Owners and staff manage products, FAQs, and policies, and handle escalated chats. The AI service only takes part in retrieving and answering.
+On the right is the data model. The important detail is that every message stores which knowledge record it used, so every automated answer can be checked later.</a:t>
             </a:r>
             <a:endParaRPr lang="en-US" dirty="0"/>
           </a:p>
@@ -1108,7 +1126,9 @@
           <a:p>
             <a:r>
               <a:rPr lang="en-US" dirty="0"/>
-              <a:t>BR means business rule: fixed rules written in the application code that the AI cannot override. The most important is BR3: refunds, complaints and discounts not in the policy always go to a real person.</a:t>
+              <a:t>[0:50]  Point to BR3 last.
+These are the business rules, BR one to eight. They are written in the application code, so the AI cannot override them. For example, only active records are used, one seller's data never reaches another seller's customers, prices quoted must match the record exactly, and card numbers are masked.
+The most important is BR3: refunds, complaints, and discounts not in the policy always go to a real person.</a:t>
             </a:r>
             <a:endParaRPr lang="en-US" dirty="0"/>
           </a:p>
@@ -1196,7 +1216,9 @@
           <a:p>
             <a:r>
               <a:rPr lang="en-US" dirty="0"/>
-              <a:t>Customer side: mobile-first chat that says replies are automated, shows which record each answer came from, follows the customer's language, and always has a Staff button. Owner side: a dashboard with weekly counts, the escalation queue with an 'Add FAQ' action, top questions, and a reminder for products not updated recently. Values shown are samples for illustration.</a:t>
+              <a:t>[0:50]  Left mockup, then right mockup.
+On the left is the customer chat, designed for mobile because most buyers message from their phones. It says clearly that replies are automated, it shows which record each answer came from, it replies in the customer's language, here in Taglish, and there is always a Staff button.
+On the right is the owner dashboard. It shows weekly counts, the chats waiting for staff, the most common questions, and a reminder when stock hasn't been updated. The numbers here are sample values only.</a:t>
             </a:r>
             <a:endParaRPr lang="en-US" dirty="0"/>
           </a:p>
@@ -1284,7 +1306,9 @@
           <a:p>
             <a:r>
               <a:rPr lang="en-US" dirty="0"/>
-              <a:t>The stack is small and affordable: a responsive web app, a REST API, a hosted LLM through a neutral interface, and PostgreSQL with pgvector on a small cloud server. Security covers both standard web controls and AI-specific ones from the OWASP LLM Top 10, such as prompt injection. Privacy follows the Data Privacy Act and NPC Advisory 2024-04.</a:t>
+              <a:t>[0:45]  Left list briefly, then the security box.
+Technically, the system is small and affordable: a web app, a REST API, a hosted AI model, and PostgreSQL with vector search on one small cloud server.
+For security and privacy: customer messages are treated as data, never as instructions; replies are checked against the record before sending; sensitive numbers are masked; chats are kept for 90 days and are never used to train models. The design follows the Data Privacy Act and NPC Advisory 2024-04.</a:t>
             </a:r>
             <a:endParaRPr lang="en-US" dirty="0"/>
           </a:p>
@@ -1372,7 +1396,9 @@
           <a:p>
             <a:r>
               <a:rPr lang="en-US" dirty="0"/>
-              <a:t>B2B subscription: the seller pays. A free tier lets sellers try it, Starter at 499 pesos fits most micro sellers, Growth at 1,299 for busier shops. These are planning figures and the survey asks about willingness to pay. Sustainability: exact FAQ matches skip the AI call, and each tier has a usage cap. First market: sellers who finished DTI or DICT digital-selling programs.</a:t>
+              <a:t>[0:50]  Point to the Starter tier.
+The business model is B2B software-as-a-service. The seller pays, not the buyer. There is a free tier so sellers can try it, a Starter tier at 499 pesos a month for most micro sellers, and a Growth tier at 1,299 pesos for busier shops. These are planning figures, and my survey asks sellers what they would actually pay.
+To keep it sustainable, simple FAQ matches skip the AI completely, and each tier has a usage limit. The first market would be sellers who finished DTI and DICT digital-selling programs.</a:t>
             </a:r>
             <a:endParaRPr lang="en-US" dirty="0"/>
           </a:p>
@@ -1460,7 +1486,9 @@
           <a:p>
             <a:r>
               <a:rPr lang="en-US" dirty="0"/>
-              <a:t>These are project targets, not industry benchmarks. Accuracy is the main measure. The test set has 120 questions, 40 per language, and the correct answer for each is written before testing so it can't be adjusted after. No performance results are claimed until the prototype is tested.</a:t>
+              <a:t>[0:50]  Point to 90% and 100%.
+These are my evaluation targets. At least 90 percent accuracy, replies within five seconds, a usability score of at least 70, satisfaction of at least 4 out of 5, and 100 percent of critical cases sent to a person. I also set a language target: the accuracy gap between English, Filipino, and Taglish should be no more than 10 points.
+I will test with 120 questions, 40 per language, and the correct answers are written down before testing. I want to be clear: these are targets. No results are claimed until the prototype is tested.</a:t>
             </a:r>
             <a:endParaRPr lang="en-US" dirty="0"/>
           </a:p>
@@ -1548,7 +1576,9 @@
           <a:p>
             <a:r>
               <a:rPr lang="en-US" dirty="0"/>
-              <a:t>This is the everyday problem. Small sellers in Baguio and Benguet mostly sell through Facebook pages and Messenger. The same questions come again and again: available pa, how much, COD, delivery time, returns. One or two people answer all of them while also running the business. Speed is one issue; consistency is another, because prices and stock change.</a:t>
+              <a:t>[1:00]  Point to the inbox on the left.
+Let me start with a picture many of us know. This is a typical inbox of a small online shop. "Hi po, avail pa?" "hm po?" "COD po ba?" "Ilang days delivery sa La Trinidad?"
+In most small shops, the person answering these messages is the owner, who is also packing orders, restocking, and booking couriers. So the first problem is time. The second is consistency: prices and stock change, and a reply typed from memory can easily be wrong. The third is after-hours messages. Customers message at night, and a late reply can mean a lost sale.</a:t>
             </a:r>
             <a:endParaRPr lang="en-US" dirty="0"/>
           </a:p>
@@ -1636,7 +1666,9 @@
           <a:p>
             <a:r>
               <a:rPr lang="en-US" dirty="0"/>
-              <a:t>Two instruments. Survey A, before building, confirms the actual needs of local sellers and starts with a screening question, so only businesses that sell or take inquiries online are included. Survey B, after testing, measures the evaluation targets including the SUS. Recruitment is through a request letter to DTI, DICT-CAR and the city office asking them to forward the survey, plus seller groups and referrals. No participant lists are requested, in line with the Data Privacy Act.</a:t>
+              <a:t>[0:50]  Survey A, Survey B, then the channels.
+For data collection, I prepared two instruments. Survey A is for sellers, before building. It starts with a screening question so only businesses that sell online are included. Survey B is the evaluation after testing, including the System Usability Scale.
+To reach sellers, I prepared a request letter to DTI, DICT-CAR, and the Baguio City office, asking them to forward the survey. I am not asking for any participant lists, in line with the Data Privacy Act. I'll also reach sellers through local Facebook groups, bazaars, and referrals. The next step is your approval of these instruments, po.</a:t>
             </a:r>
             <a:endParaRPr lang="en-US" dirty="0"/>
           </a:p>
@@ -1724,7 +1756,9 @@
           <a:p>
             <a:r>
               <a:rPr lang="en-US" dirty="0"/>
-              <a:t>To conclude: sellers are being encouraged to go online, and answering customers becomes a daily burden. The design answers only from the owner's records, works in Taglish and hands off to staff. It acts as a helper, not a decision-maker. Recommendations: build and test as planned, confirm requirements with sellers, keep escalation strict, add Messenger next, and partner with DTI and DICT.</a:t>
+              <a:t>[1:00]  Slow down here.
+To conclude. Small sellers in Baguio and Benguet are being encouraged to sell online, and answering customers is becoming a daily burden for one- or two-person shops. My design answers only from the owner's records, works in Taglish, and hands off to staff when it should. Of the four options, it was the only one that gave owners control over the facts while still reducing their workload. The AI is a helper, not a decision-maker.
+My recommendations are: build and test the prototype, and report results only after testing; confirm the requirements with sellers before the second sprint; keep the escalation rules strict at the start; add Messenger integration next; and work with DTI and DICT as a follow-up to their training.</a:t>
             </a:r>
             <a:endParaRPr lang="en-US" dirty="0"/>
           </a:p>
@@ -1812,7 +1846,8 @@
           <a:p>
             <a:r>
               <a:rPr lang="en-US" dirty="0"/>
-              <a:t>Full ACM-formatted reference list (30 entries) is in the paper.</a:t>
+              <a:t>[0:10]  Do not read this slide.
+These are my main references. The complete list of thirty sources, in ACM format, is in the paper.</a:t>
             </a:r>
             <a:endParaRPr lang="en-US" dirty="0"/>
           </a:p>
@@ -1900,7 +1935,9 @@
           <a:p>
             <a:r>
               <a:rPr lang="en-US" dirty="0"/>
-              <a:t>Thank the panel and invite questions. Be ready for: why not ChatGPT, how you know local sellers have this problem, what if the AI is wrong, Taglish handling, privacy, who pays, where are the results, and what's new compared with ChatGenie or iTANONG.</a:t>
+              <a:t>[0:20]  Say the quote slowly, then open the floor.
+I'll end with the one idea behind the whole design: the owner's records, not the AI's general knowledge, decide what customers are told.
+Maraming salamat po. I'm happy to answer your questions and hear your suggestions.</a:t>
             </a:r>
             <a:endParaRPr lang="en-US" dirty="0"/>
           </a:p>
@@ -1988,7 +2025,9 @@
           <a:p>
             <a:r>
               <a:rPr lang="en-US" dirty="0"/>
-              <a:t>Four numbers set the context. Almost all Philippine businesses are MSMEs. The digital economy is almost 10 percent of GDP and e-commerce is about a third of it. Most online sellers use social media, and most accept COD. So for a small seller, customer questions arrive in Messenger, not in a help desk system.</a:t>
+              <a:t>[1:15]  Pause briefly on each number.
+This is not a small issue. According to DTI, 99.63 percent of business establishments in the country are MSMEs. The PSA estimates that the digital economy is 9.8 percent of our GDP, and about a third of that is e-commerce.
+The last two numbers matter most for my design. 94.4 percent of online sellers sell through social media, and 87.9 percent accept cash on delivery. This tells us that for a typical small seller, customer questions come through Messenger and Facebook, not through a big platform with its own help desk.</a:t>
             </a:r>
             <a:endParaRPr lang="en-US" dirty="0"/>
           </a:p>
@@ -2076,7 +2115,9 @@
           <a:p>
             <a:r>
               <a:rPr lang="en-US" dirty="0"/>
-              <a:t>Locally, government programs are actively helping Baguio and Benguet MSMEs go online. Source: Philippine Information Agency reports, 2026. But these programs focus on opening and marketing stores. Handling the customer messages afterwards is the gap this study starts from. Note: these reports describe the setting; the seller survey will confirm the actual problem.</a:t>
+              <a:t>[1:15]  Move left to right along the timeline.
+Here in the Cordillera, the government is actively helping MSMEs go online. In February, DICT-CAR and DTI-CAR aligned their digital programs. In April, DTI-CAR released its MSME agenda. In July, 50 Baguio MSMEs joined the Tatak Pinoy workshop with Shopee. And in September, 25 sellers from Baguio and Benguet finished DICT's SPARK training on social media marketing.
+These programs teach sellers how to open and promote their stores. But very little attention goes to what happens next, when the messages start coming in. That is the gap where my study begins. I want to be clear that these reports describe the setting; my seller survey will confirm the actual problem.</a:t>
             </a:r>
             <a:endParaRPr lang="en-US" dirty="0"/>
           </a:p>
@@ -2164,7 +2205,9 @@
           <a:p>
             <a:r>
               <a:rPr lang="en-US" dirty="0"/>
-              <a:t>The design problem is how to build a support assistant that answers routine questions quickly and correctly, never states something the business has not approved, and hands anything difficult to a person. Specific objectives: gather requirements from sellers, design the owner-managed knowledge base, support English, Filipino and Taglish, answer only from approved records, add human escalation, and evaluate the prototype.</a:t>
+              <a:t>[1:00]  Left side first, then the objective box.
+So the problem has five parts: repeated questions take the owner's time, typed replies are not always consistent, business information keeps changing, customers write in English, Filipino, or Taglish, and some cases, like complaints and refunds, really need a person.
+My general objective is to design and develop a prototype customer support system that answers routine questions quickly and correctly, never states a fact the owner has not approved, and hands difficult cases to a person.</a:t>
             </a:r>
             <a:endParaRPr lang="en-US" dirty="0"/>
           </a:p>
@@ -2252,7 +2295,8 @@
           <a:p>
             <a:r>
               <a:rPr lang="en-US" dirty="0"/>
-              <a:t>Five research questions guide the design: seller needs, grounded answers, language handling, escalation, and evaluation.</a:t>
+              <a:t>[0:45]  Read the short labels, not every word.
+Five research questions guide the study. First, what do local sellers actually need? Second, how should the business information be stored so every answer can be traced to approved data? Third, how do we handle English, Filipino, and Taglish? Fourth, how does the system recognize when to pass a chat to staff? And fifth, how do we measure whether the prototype works?</a:t>
             </a:r>
             <a:endParaRPr lang="en-US" dirty="0"/>
           </a:p>
@@ -2340,7 +2384,12 @@
           <a:p>
             <a:r>
               <a:rPr lang="en-US" dirty="0"/>
-              <a:t>Four takeaways. First, customers care about correct, concrete answers, not just speed. Second, Huang, Markovitch and Stough found that chatbot service with light human help matched human-only service. This shaped the escalation design. Third, a Philippine study of Shopee and Lazada chatbots found users struggled with dialogue and understanding. Fourth, AI models are weaker in Tagalog and Taglish, so the system must be tested per language. Also mentioned in the paper: Data Privacy Act, NPC Advisory 2024-04, NIST AI RMF, OWASP LLM Top 10.</a:t>
+              <a:t>[1:15]  Spend the most time on the top-right card.
+From the literature, four lessons shaped my design.
+First, customers value correct, concrete answers more than speed alone. A fast wrong answer is worse than a slower correct one.
+Second, and this is the most important one for me: Huang and colleagues ran three studies with 643 participants and found that a chatbot with light human help matched human-only service on most outcomes. So we don't need to choose between full automation and doing everything by hand.
+Third, a Philippine study of the Shopee and Lazada chatbots found that Filipino users struggled with how the bots understood them.
+And fourth, AI models still perform unevenly in Tagalog and Taglish, so language must be tested on its own.</a:t>
             </a:r>
             <a:endParaRPr lang="en-US" dirty="0"/>
           </a:p>
@@ -2428,7 +2477,9 @@
           <a:p>
             <a:r>
               <a:rPr lang="en-US" dirty="0"/>
-              <a:t>Parts of this idea already exist in the Philippines: shop chatbots in Nueva Ecija, the Shopee and Lazada bots, DOST-ASTI's iTANONG which answers in Taglish from approved data, and ChatGenie for MSME chat commerce. But none combines owner-controlled answers, Taglish testing and human hand-off for micro sellers, and none is in the Cordillera. That is the gap.</a:t>
+              <a:t>[1:00]  Point to the 'Used in the PH?' column, then the red box.
+Has something like this been done in the Philippines? Partly. Online shops in Nueva Ecija already use chatbots. Shopee and Lazada have them. DOST-ASTI's iTANONG answers in Taglish from approved government data. And ChatGenie helps MSMEs sell through chat apps. In Ecuador, a similar MSME chatbot study reported high usability.
+But none of these combines three things: answers controlled by the owner, testing in Taglish, and a built-in hand-off to a person, for micro sellers. And none is in Baguio or Benguet. That is the gap this study addresses.</a:t>
             </a:r>
             <a:endParaRPr lang="en-US" dirty="0"/>
           </a:p>
@@ -2516,7 +2567,9 @@
           <a:p>
             <a:r>
               <a:rPr lang="en-US" dirty="0"/>
-              <a:t>This is a design project following the design-science pattern: identify the problem, build the artifact, evaluate it. Development follows Agile, adapted from Scrum, with six two-week sprints. Agile fits because the seller interviews may change the knowledge-base fields and escalation rules during development.</a:t>
+              <a:t>[0:50]  Top row, then the sprint boxes.
+Methodologically, this is a design project following the design-science pattern: identify the problem, build the artifact, then evaluate it.
+Development follows Agile, adapted from Scrum, in six two-week sprints. Sprint zero is for seller interviews and requirements. I chose Agile because what sellers tell me may change the design along the way, for example the fields in the knowledge base or the escalation rules.</a:t>
             </a:r>
             <a:endParaRPr lang="en-US" dirty="0"/>
           </a:p>

</xml_diff>